<commit_message>
Update CarometroTalentReview.pptx with new content
</commit_message>
<xml_diff>
--- a/carometros/CarometroTalentReview.pptx
+++ b/carometros/CarometroTalentReview.pptx
@@ -205,7 +205,7 @@
           </a:lstStyle>
           <a:p>
             <a:fld id="{D647AD4C-97C8-428C-9142-EE5D77E39178}" type="datetimeFigureOut">
-              <a:t>13/04/2026</a:t>
+              <a:t>17/04/2026</a:t>
             </a:fld>
             <a:endParaRPr lang="pt-BR"/>
           </a:p>
@@ -719,7 +719,7 @@
           <a:p>
             <a:fld id="{F0E51C7C-CEA3-4CAA-BE4B-344879E7C377}" type="datetimeFigureOut">
               <a:rPr lang="de-DE" smtClean="0"/>
-              <a:t>13.04.2026</a:t>
+              <a:t>17.04.2026</a:t>
             </a:fld>
             <a:endParaRPr lang="de-DE"/>
           </a:p>
@@ -889,7 +889,7 @@
           <a:p>
             <a:fld id="{F0E51C7C-CEA3-4CAA-BE4B-344879E7C377}" type="datetimeFigureOut">
               <a:rPr lang="de-DE" smtClean="0"/>
-              <a:t>13.04.2026</a:t>
+              <a:t>17.04.2026</a:t>
             </a:fld>
             <a:endParaRPr lang="de-DE"/>
           </a:p>
@@ -1069,7 +1069,7 @@
           <a:p>
             <a:fld id="{F0E51C7C-CEA3-4CAA-BE4B-344879E7C377}" type="datetimeFigureOut">
               <a:rPr lang="de-DE" smtClean="0"/>
-              <a:t>13.04.2026</a:t>
+              <a:t>17.04.2026</a:t>
             </a:fld>
             <a:endParaRPr lang="de-DE"/>
           </a:p>
@@ -1239,7 +1239,7 @@
           <a:p>
             <a:fld id="{F0E51C7C-CEA3-4CAA-BE4B-344879E7C377}" type="datetimeFigureOut">
               <a:rPr lang="de-DE" smtClean="0"/>
-              <a:t>13.04.2026</a:t>
+              <a:t>17.04.2026</a:t>
             </a:fld>
             <a:endParaRPr lang="de-DE"/>
           </a:p>
@@ -1485,7 +1485,7 @@
           <a:p>
             <a:fld id="{F0E51C7C-CEA3-4CAA-BE4B-344879E7C377}" type="datetimeFigureOut">
               <a:rPr lang="de-DE" smtClean="0"/>
-              <a:t>13.04.2026</a:t>
+              <a:t>17.04.2026</a:t>
             </a:fld>
             <a:endParaRPr lang="de-DE"/>
           </a:p>
@@ -1717,7 +1717,7 @@
           <a:p>
             <a:fld id="{F0E51C7C-CEA3-4CAA-BE4B-344879E7C377}" type="datetimeFigureOut">
               <a:rPr lang="de-DE" smtClean="0"/>
-              <a:t>13.04.2026</a:t>
+              <a:t>17.04.2026</a:t>
             </a:fld>
             <a:endParaRPr lang="de-DE"/>
           </a:p>
@@ -2084,7 +2084,7 @@
           <a:p>
             <a:fld id="{F0E51C7C-CEA3-4CAA-BE4B-344879E7C377}" type="datetimeFigureOut">
               <a:rPr lang="de-DE" smtClean="0"/>
-              <a:t>13.04.2026</a:t>
+              <a:t>17.04.2026</a:t>
             </a:fld>
             <a:endParaRPr lang="de-DE"/>
           </a:p>
@@ -2202,7 +2202,7 @@
           <a:p>
             <a:fld id="{F0E51C7C-CEA3-4CAA-BE4B-344879E7C377}" type="datetimeFigureOut">
               <a:rPr lang="de-DE" smtClean="0"/>
-              <a:t>13.04.2026</a:t>
+              <a:t>17.04.2026</a:t>
             </a:fld>
             <a:endParaRPr lang="de-DE"/>
           </a:p>
@@ -2297,7 +2297,7 @@
           <a:p>
             <a:fld id="{F0E51C7C-CEA3-4CAA-BE4B-344879E7C377}" type="datetimeFigureOut">
               <a:rPr lang="de-DE" smtClean="0"/>
-              <a:t>13.04.2026</a:t>
+              <a:t>17.04.2026</a:t>
             </a:fld>
             <a:endParaRPr lang="de-DE"/>
           </a:p>
@@ -2574,7 +2574,7 @@
           <a:p>
             <a:fld id="{F0E51C7C-CEA3-4CAA-BE4B-344879E7C377}" type="datetimeFigureOut">
               <a:rPr lang="de-DE" smtClean="0"/>
-              <a:t>13.04.2026</a:t>
+              <a:t>17.04.2026</a:t>
             </a:fld>
             <a:endParaRPr lang="de-DE"/>
           </a:p>
@@ -2827,7 +2827,7 @@
           <a:p>
             <a:fld id="{F0E51C7C-CEA3-4CAA-BE4B-344879E7C377}" type="datetimeFigureOut">
               <a:rPr lang="de-DE" smtClean="0"/>
-              <a:t>13.04.2026</a:t>
+              <a:t>17.04.2026</a:t>
             </a:fld>
             <a:endParaRPr lang="de-DE"/>
           </a:p>
@@ -3040,7 +3040,7 @@
           <a:p>
             <a:fld id="{F0E51C7C-CEA3-4CAA-BE4B-344879E7C377}" type="datetimeFigureOut">
               <a:rPr lang="de-DE" smtClean="0"/>
-              <a:t>13.04.2026</a:t>
+              <a:t>17.04.2026</a:t>
             </a:fld>
             <a:endParaRPr lang="de-DE"/>
           </a:p>
@@ -4972,7 +4972,7 @@
           <p:nvPr/>
         </p:nvPicPr>
         <p:blipFill>
-          <a:blip r:embed="rId3">
+          <a:blip r:embed="rId3" cstate="print">
             <a:extLst>
               <a:ext uri="{28A0092B-C50C-407E-A947-70E740481C1C}">
                 <a14:useLocalDpi xmlns:a14="http://schemas.microsoft.com/office/drawing/2010/main" val="0"/>
@@ -4984,7 +4984,7 @@
         </p:blipFill>
         <p:spPr>
           <a:xfrm>
-            <a:off x="413121" y="1331176"/>
+            <a:off x="413121" y="1296476"/>
             <a:ext cx="455144" cy="468000"/>
           </a:xfrm>
           <a:prstGeom prst="ellipse">
@@ -5008,233 +5008,6 @@
           </a:sp3d>
         </p:spPr>
       </p:pic>
-      <p:sp>
-        <p:nvSpPr>
-          <p:cNvPr id="14" name="CaixaDeTexto 13">
-            <a:extLst>
-              <a:ext uri="{FF2B5EF4-FFF2-40B4-BE49-F238E27FC236}">
-                <a16:creationId xmlns:a16="http://schemas.microsoft.com/office/drawing/2014/main" id="{B493837A-AD3E-D666-FD68-7FF996261A7D}"/>
-              </a:ext>
-            </a:extLst>
-          </p:cNvPr>
-          <p:cNvSpPr txBox="1"/>
-          <p:nvPr/>
-        </p:nvSpPr>
-        <p:spPr>
-          <a:xfrm>
-            <a:off x="975217" y="1244568"/>
-            <a:ext cx="3110367" cy="861774"/>
-          </a:xfrm>
-          <a:prstGeom prst="rect">
-            <a:avLst/>
-          </a:prstGeom>
-          <a:noFill/>
-        </p:spPr>
-        <p:txBody>
-          <a:bodyPr wrap="square" lIns="60960" tIns="30480" rIns="60960" bIns="30480" anchor="t">
-            <a:spAutoFit/>
-          </a:bodyPr>
-          <a:lstStyle>
-            <a:defPPr>
-              <a:defRPr lang="en-US"/>
-            </a:defPPr>
-            <a:lvl1pPr marL="0" algn="l" defTabSz="609539" rtl="0" eaLnBrk="1" latinLnBrk="0" hangingPunct="1">
-              <a:defRPr sz="1200" kern="1200">
-                <a:solidFill>
-                  <a:schemeClr val="tx1"/>
-                </a:solidFill>
-                <a:latin typeface="+mn-lt"/>
-                <a:ea typeface="+mn-ea"/>
-                <a:cs typeface="+mn-cs"/>
-              </a:defRPr>
-            </a:lvl1pPr>
-            <a:lvl2pPr marL="304770" algn="l" defTabSz="609539" rtl="0" eaLnBrk="1" latinLnBrk="0" hangingPunct="1">
-              <a:defRPr sz="1200" kern="1200">
-                <a:solidFill>
-                  <a:schemeClr val="tx1"/>
-                </a:solidFill>
-                <a:latin typeface="+mn-lt"/>
-                <a:ea typeface="+mn-ea"/>
-                <a:cs typeface="+mn-cs"/>
-              </a:defRPr>
-            </a:lvl2pPr>
-            <a:lvl3pPr marL="609539" algn="l" defTabSz="609539" rtl="0" eaLnBrk="1" latinLnBrk="0" hangingPunct="1">
-              <a:defRPr sz="1200" kern="1200">
-                <a:solidFill>
-                  <a:schemeClr val="tx1"/>
-                </a:solidFill>
-                <a:latin typeface="+mn-lt"/>
-                <a:ea typeface="+mn-ea"/>
-                <a:cs typeface="+mn-cs"/>
-              </a:defRPr>
-            </a:lvl3pPr>
-            <a:lvl4pPr marL="914309" algn="l" defTabSz="609539" rtl="0" eaLnBrk="1" latinLnBrk="0" hangingPunct="1">
-              <a:defRPr sz="1200" kern="1200">
-                <a:solidFill>
-                  <a:schemeClr val="tx1"/>
-                </a:solidFill>
-                <a:latin typeface="+mn-lt"/>
-                <a:ea typeface="+mn-ea"/>
-                <a:cs typeface="+mn-cs"/>
-              </a:defRPr>
-            </a:lvl4pPr>
-            <a:lvl5pPr marL="1219078" algn="l" defTabSz="609539" rtl="0" eaLnBrk="1" latinLnBrk="0" hangingPunct="1">
-              <a:defRPr sz="1200" kern="1200">
-                <a:solidFill>
-                  <a:schemeClr val="tx1"/>
-                </a:solidFill>
-                <a:latin typeface="+mn-lt"/>
-                <a:ea typeface="+mn-ea"/>
-                <a:cs typeface="+mn-cs"/>
-              </a:defRPr>
-            </a:lvl5pPr>
-            <a:lvl6pPr marL="1523848" algn="l" defTabSz="609539" rtl="0" eaLnBrk="1" latinLnBrk="0" hangingPunct="1">
-              <a:defRPr sz="1200" kern="1200">
-                <a:solidFill>
-                  <a:schemeClr val="tx1"/>
-                </a:solidFill>
-                <a:latin typeface="+mn-lt"/>
-                <a:ea typeface="+mn-ea"/>
-                <a:cs typeface="+mn-cs"/>
-              </a:defRPr>
-            </a:lvl6pPr>
-            <a:lvl7pPr marL="1828617" algn="l" defTabSz="609539" rtl="0" eaLnBrk="1" latinLnBrk="0" hangingPunct="1">
-              <a:defRPr sz="1200" kern="1200">
-                <a:solidFill>
-                  <a:schemeClr val="tx1"/>
-                </a:solidFill>
-                <a:latin typeface="+mn-lt"/>
-                <a:ea typeface="+mn-ea"/>
-                <a:cs typeface="+mn-cs"/>
-              </a:defRPr>
-            </a:lvl7pPr>
-            <a:lvl8pPr marL="2133387" algn="l" defTabSz="609539" rtl="0" eaLnBrk="1" latinLnBrk="0" hangingPunct="1">
-              <a:defRPr sz="1200" kern="1200">
-                <a:solidFill>
-                  <a:schemeClr val="tx1"/>
-                </a:solidFill>
-                <a:latin typeface="+mn-lt"/>
-                <a:ea typeface="+mn-ea"/>
-                <a:cs typeface="+mn-cs"/>
-              </a:defRPr>
-            </a:lvl8pPr>
-            <a:lvl9pPr marL="2438156" algn="l" defTabSz="609539" rtl="0" eaLnBrk="1" latinLnBrk="0" hangingPunct="1">
-              <a:defRPr sz="1200" kern="1200">
-                <a:solidFill>
-                  <a:schemeClr val="tx1"/>
-                </a:solidFill>
-                <a:latin typeface="+mn-lt"/>
-                <a:ea typeface="+mn-ea"/>
-                <a:cs typeface="+mn-cs"/>
-              </a:defRPr>
-            </a:lvl9pPr>
-          </a:lstStyle>
-          <a:p>
-            <a:r>
-              <a:rPr lang="pt-BR" sz="1000" dirty="0">
-                <a:latin typeface="Calibri"/>
-                <a:ea typeface="Calibri"/>
-                <a:cs typeface="Calibri"/>
-              </a:rPr>
-              <a:t>NOME COMPLETO | IDADE  - NOTA/POTENCIAL</a:t>
-            </a:r>
-          </a:p>
-          <a:p>
-            <a:pPr algn="l">
-              <a:lnSpc>
-                <a:spcPct val="100000"/>
-              </a:lnSpc>
-            </a:pPr>
-            <a:r>
-              <a:rPr lang="en-US" sz="1000">
-                <a:latin typeface="Calibri"/>
-                <a:ea typeface="Calibri"/>
-                <a:cs typeface="Calibri"/>
-              </a:rPr>
-              <a:t>CARGO</a:t>
-            </a:r>
-          </a:p>
-          <a:p>
-            <a:pPr algn="l">
-              <a:lnSpc>
-                <a:spcPct val="100000"/>
-              </a:lnSpc>
-            </a:pPr>
-            <a:r>
-              <a:rPr lang="pt-BR" sz="800">
-                <a:solidFill>
-                  <a:schemeClr val="bg1"/>
-                </a:solidFill>
-                <a:highlight>
-                  <a:srgbClr val="84BD00"/>
-                </a:highlight>
-                <a:latin typeface="Aptos Narrow"/>
-                <a:ea typeface="Calibri"/>
-                <a:cs typeface="Calibri"/>
-              </a:rPr>
-              <a:t>Sucessor Imediato</a:t>
-            </a:r>
-          </a:p>
-          <a:p>
-            <a:pPr algn="l">
-              <a:lnSpc>
-                <a:spcPct val="100000"/>
-              </a:lnSpc>
-            </a:pPr>
-            <a:r>
-              <a:rPr lang="pt-BR" sz="800">
-                <a:solidFill>
-                  <a:srgbClr val="242424"/>
-                </a:solidFill>
-                <a:latin typeface="Aptos Narrow"/>
-                <a:ea typeface="Calibri"/>
-                <a:cs typeface="Calibri"/>
-              </a:rPr>
-              <a:t>LOREM</a:t>
-            </a:r>
-            <a:endParaRPr lang="pt-BR"/>
-          </a:p>
-          <a:p>
-            <a:pPr algn="l">
-              <a:lnSpc>
-                <a:spcPct val="100000"/>
-              </a:lnSpc>
-            </a:pPr>
-            <a:r>
-              <a:rPr lang="pt-BR" sz="800">
-                <a:solidFill>
-                  <a:schemeClr val="bg1"/>
-                </a:solidFill>
-                <a:highlight>
-                  <a:srgbClr val="0000FF"/>
-                </a:highlight>
-                <a:latin typeface="Aptos Narrow"/>
-                <a:ea typeface="Calibri"/>
-                <a:cs typeface="Calibri"/>
-              </a:rPr>
-              <a:t>Em desenvolvimento</a:t>
-            </a:r>
-          </a:p>
-          <a:p>
-            <a:pPr algn="l">
-              <a:lnSpc>
-                <a:spcPct val="100000"/>
-              </a:lnSpc>
-            </a:pPr>
-            <a:r>
-              <a:rPr lang="pt-BR" sz="800">
-                <a:solidFill>
-                  <a:srgbClr val="242424"/>
-                </a:solidFill>
-                <a:latin typeface="Aptos Narrow"/>
-                <a:ea typeface="Calibri"/>
-                <a:cs typeface="Calibri"/>
-              </a:rPr>
-              <a:t>LOREM</a:t>
-            </a:r>
-          </a:p>
-        </p:txBody>
-      </p:sp>
       <p:grpSp>
         <p:nvGrpSpPr>
           <p:cNvPr id="105" name="Agrupar 104">
@@ -5423,14 +5196,241 @@
                 </a:lnSpc>
               </a:pPr>
               <a:r>
-                <a:rPr lang="pt-BR" sz="1000"/>
+                <a:rPr lang="pt-BR" sz="1000" dirty="0"/>
                 <a:t>CEO4</a:t>
               </a:r>
-              <a:endParaRPr lang="pt-BR"/>
+              <a:endParaRPr lang="pt-BR" dirty="0"/>
             </a:p>
           </p:txBody>
         </p:sp>
       </p:grpSp>
+      <p:sp>
+        <p:nvSpPr>
+          <p:cNvPr id="14" name="CaixaDeTexto 13">
+            <a:extLst>
+              <a:ext uri="{FF2B5EF4-FFF2-40B4-BE49-F238E27FC236}">
+                <a16:creationId xmlns:a16="http://schemas.microsoft.com/office/drawing/2014/main" id="{B493837A-AD3E-D666-FD68-7FF996261A7D}"/>
+              </a:ext>
+            </a:extLst>
+          </p:cNvPr>
+          <p:cNvSpPr txBox="1"/>
+          <p:nvPr/>
+        </p:nvSpPr>
+        <p:spPr>
+          <a:xfrm>
+            <a:off x="975217" y="1296476"/>
+            <a:ext cx="3110367" cy="861774"/>
+          </a:xfrm>
+          <a:prstGeom prst="rect">
+            <a:avLst/>
+          </a:prstGeom>
+          <a:noFill/>
+        </p:spPr>
+        <p:txBody>
+          <a:bodyPr wrap="square" lIns="60960" tIns="30480" rIns="60960" bIns="30480" anchor="t">
+            <a:spAutoFit/>
+          </a:bodyPr>
+          <a:lstStyle>
+            <a:defPPr>
+              <a:defRPr lang="en-US"/>
+            </a:defPPr>
+            <a:lvl1pPr marL="0" algn="l" defTabSz="609539" rtl="0" eaLnBrk="1" latinLnBrk="0" hangingPunct="1">
+              <a:defRPr sz="1200" kern="1200">
+                <a:solidFill>
+                  <a:schemeClr val="tx1"/>
+                </a:solidFill>
+                <a:latin typeface="+mn-lt"/>
+                <a:ea typeface="+mn-ea"/>
+                <a:cs typeface="+mn-cs"/>
+              </a:defRPr>
+            </a:lvl1pPr>
+            <a:lvl2pPr marL="304770" algn="l" defTabSz="609539" rtl="0" eaLnBrk="1" latinLnBrk="0" hangingPunct="1">
+              <a:defRPr sz="1200" kern="1200">
+                <a:solidFill>
+                  <a:schemeClr val="tx1"/>
+                </a:solidFill>
+                <a:latin typeface="+mn-lt"/>
+                <a:ea typeface="+mn-ea"/>
+                <a:cs typeface="+mn-cs"/>
+              </a:defRPr>
+            </a:lvl2pPr>
+            <a:lvl3pPr marL="609539" algn="l" defTabSz="609539" rtl="0" eaLnBrk="1" latinLnBrk="0" hangingPunct="1">
+              <a:defRPr sz="1200" kern="1200">
+                <a:solidFill>
+                  <a:schemeClr val="tx1"/>
+                </a:solidFill>
+                <a:latin typeface="+mn-lt"/>
+                <a:ea typeface="+mn-ea"/>
+                <a:cs typeface="+mn-cs"/>
+              </a:defRPr>
+            </a:lvl3pPr>
+            <a:lvl4pPr marL="914309" algn="l" defTabSz="609539" rtl="0" eaLnBrk="1" latinLnBrk="0" hangingPunct="1">
+              <a:defRPr sz="1200" kern="1200">
+                <a:solidFill>
+                  <a:schemeClr val="tx1"/>
+                </a:solidFill>
+                <a:latin typeface="+mn-lt"/>
+                <a:ea typeface="+mn-ea"/>
+                <a:cs typeface="+mn-cs"/>
+              </a:defRPr>
+            </a:lvl4pPr>
+            <a:lvl5pPr marL="1219078" algn="l" defTabSz="609539" rtl="0" eaLnBrk="1" latinLnBrk="0" hangingPunct="1">
+              <a:defRPr sz="1200" kern="1200">
+                <a:solidFill>
+                  <a:schemeClr val="tx1"/>
+                </a:solidFill>
+                <a:latin typeface="+mn-lt"/>
+                <a:ea typeface="+mn-ea"/>
+                <a:cs typeface="+mn-cs"/>
+              </a:defRPr>
+            </a:lvl5pPr>
+            <a:lvl6pPr marL="1523848" algn="l" defTabSz="609539" rtl="0" eaLnBrk="1" latinLnBrk="0" hangingPunct="1">
+              <a:defRPr sz="1200" kern="1200">
+                <a:solidFill>
+                  <a:schemeClr val="tx1"/>
+                </a:solidFill>
+                <a:latin typeface="+mn-lt"/>
+                <a:ea typeface="+mn-ea"/>
+                <a:cs typeface="+mn-cs"/>
+              </a:defRPr>
+            </a:lvl6pPr>
+            <a:lvl7pPr marL="1828617" algn="l" defTabSz="609539" rtl="0" eaLnBrk="1" latinLnBrk="0" hangingPunct="1">
+              <a:defRPr sz="1200" kern="1200">
+                <a:solidFill>
+                  <a:schemeClr val="tx1"/>
+                </a:solidFill>
+                <a:latin typeface="+mn-lt"/>
+                <a:ea typeface="+mn-ea"/>
+                <a:cs typeface="+mn-cs"/>
+              </a:defRPr>
+            </a:lvl7pPr>
+            <a:lvl8pPr marL="2133387" algn="l" defTabSz="609539" rtl="0" eaLnBrk="1" latinLnBrk="0" hangingPunct="1">
+              <a:defRPr sz="1200" kern="1200">
+                <a:solidFill>
+                  <a:schemeClr val="tx1"/>
+                </a:solidFill>
+                <a:latin typeface="+mn-lt"/>
+                <a:ea typeface="+mn-ea"/>
+                <a:cs typeface="+mn-cs"/>
+              </a:defRPr>
+            </a:lvl8pPr>
+            <a:lvl9pPr marL="2438156" algn="l" defTabSz="609539" rtl="0" eaLnBrk="1" latinLnBrk="0" hangingPunct="1">
+              <a:defRPr sz="1200" kern="1200">
+                <a:solidFill>
+                  <a:schemeClr val="tx1"/>
+                </a:solidFill>
+                <a:latin typeface="+mn-lt"/>
+                <a:ea typeface="+mn-ea"/>
+                <a:cs typeface="+mn-cs"/>
+              </a:defRPr>
+            </a:lvl9pPr>
+          </a:lstStyle>
+          <a:p>
+            <a:r>
+              <a:rPr lang="pt-BR" sz="1000" dirty="0">
+                <a:latin typeface="Calibri"/>
+                <a:ea typeface="Calibri"/>
+                <a:cs typeface="Calibri"/>
+              </a:rPr>
+              <a:t>NOME COMPLETO | IDADE  - NOTA/POTENCIAL</a:t>
+            </a:r>
+          </a:p>
+          <a:p>
+            <a:pPr algn="l">
+              <a:lnSpc>
+                <a:spcPct val="100000"/>
+              </a:lnSpc>
+            </a:pPr>
+            <a:r>
+              <a:rPr lang="en-US" sz="1000">
+                <a:latin typeface="Calibri"/>
+                <a:ea typeface="Calibri"/>
+                <a:cs typeface="Calibri"/>
+              </a:rPr>
+              <a:t>CARGO</a:t>
+            </a:r>
+          </a:p>
+          <a:p>
+            <a:pPr algn="l">
+              <a:lnSpc>
+                <a:spcPct val="100000"/>
+              </a:lnSpc>
+            </a:pPr>
+            <a:r>
+              <a:rPr lang="pt-BR" sz="800">
+                <a:solidFill>
+                  <a:schemeClr val="bg1"/>
+                </a:solidFill>
+                <a:highlight>
+                  <a:srgbClr val="84BD00"/>
+                </a:highlight>
+                <a:latin typeface="Aptos Narrow"/>
+                <a:ea typeface="Calibri"/>
+                <a:cs typeface="Calibri"/>
+              </a:rPr>
+              <a:t>Sucessor Imediato</a:t>
+            </a:r>
+          </a:p>
+          <a:p>
+            <a:pPr algn="l">
+              <a:lnSpc>
+                <a:spcPct val="100000"/>
+              </a:lnSpc>
+            </a:pPr>
+            <a:r>
+              <a:rPr lang="pt-BR" sz="800">
+                <a:solidFill>
+                  <a:srgbClr val="242424"/>
+                </a:solidFill>
+                <a:latin typeface="Aptos Narrow"/>
+                <a:ea typeface="Calibri"/>
+                <a:cs typeface="Calibri"/>
+              </a:rPr>
+              <a:t>LOREM</a:t>
+            </a:r>
+            <a:endParaRPr lang="pt-BR"/>
+          </a:p>
+          <a:p>
+            <a:pPr algn="l">
+              <a:lnSpc>
+                <a:spcPct val="100000"/>
+              </a:lnSpc>
+            </a:pPr>
+            <a:r>
+              <a:rPr lang="pt-BR" sz="800">
+                <a:solidFill>
+                  <a:schemeClr val="bg1"/>
+                </a:solidFill>
+                <a:highlight>
+                  <a:srgbClr val="0000FF"/>
+                </a:highlight>
+                <a:latin typeface="Aptos Narrow"/>
+                <a:ea typeface="Calibri"/>
+                <a:cs typeface="Calibri"/>
+              </a:rPr>
+              <a:t>Em desenvolvimento</a:t>
+            </a:r>
+          </a:p>
+          <a:p>
+            <a:pPr algn="l">
+              <a:lnSpc>
+                <a:spcPct val="100000"/>
+              </a:lnSpc>
+            </a:pPr>
+            <a:r>
+              <a:rPr lang="pt-BR" sz="800">
+                <a:solidFill>
+                  <a:srgbClr val="242424"/>
+                </a:solidFill>
+                <a:latin typeface="Aptos Narrow"/>
+                <a:ea typeface="Calibri"/>
+                <a:cs typeface="Calibri"/>
+              </a:rPr>
+              <a:t>LOREM</a:t>
+            </a:r>
+          </a:p>
+        </p:txBody>
+      </p:sp>
       <p:pic>
         <p:nvPicPr>
           <p:cNvPr id="2" name="Imagem 1">
@@ -5446,7 +5446,7 @@
           <p:nvPr/>
         </p:nvPicPr>
         <p:blipFill>
-          <a:blip r:embed="rId4">
+          <a:blip r:embed="rId4" cstate="print">
             <a:extLst>
               <a:ext uri="{28A0092B-C50C-407E-A947-70E740481C1C}">
                 <a14:useLocalDpi xmlns:a14="http://schemas.microsoft.com/office/drawing/2010/main" val="0"/>
@@ -5458,7 +5458,58 @@
         </p:blipFill>
         <p:spPr>
           <a:xfrm>
-            <a:off x="413121" y="3501458"/>
+            <a:off x="413121" y="3151628"/>
+            <a:ext cx="455144" cy="468000"/>
+          </a:xfrm>
+          <a:prstGeom prst="ellipse">
+            <a:avLst/>
+          </a:prstGeom>
+          <a:ln w="63500" cap="rnd">
+            <a:noFill/>
+          </a:ln>
+          <a:effectLst/>
+          <a:scene3d>
+            <a:camera prst="orthographicFront"/>
+            <a:lightRig rig="contrasting" dir="t">
+              <a:rot lat="0" lon="0" rev="3000000"/>
+            </a:lightRig>
+          </a:scene3d>
+          <a:sp3d contourW="7620">
+            <a:bevelT w="95250" h="31750"/>
+            <a:contourClr>
+              <a:srgbClr val="333333"/>
+            </a:contourClr>
+          </a:sp3d>
+        </p:spPr>
+      </p:pic>
+      <p:pic>
+        <p:nvPicPr>
+          <p:cNvPr id="12" name="Imagem 11">
+            <a:extLst>
+              <a:ext uri="{FF2B5EF4-FFF2-40B4-BE49-F238E27FC236}">
+                <a16:creationId xmlns:a16="http://schemas.microsoft.com/office/drawing/2014/main" id="{F577B933-5A81-69AF-F583-10FAAB19AED3}"/>
+              </a:ext>
+            </a:extLst>
+          </p:cNvPr>
+          <p:cNvPicPr>
+            <a:picLocks noChangeAspect="1"/>
+          </p:cNvPicPr>
+          <p:nvPr/>
+        </p:nvPicPr>
+        <p:blipFill>
+          <a:blip r:embed="rId5" cstate="print">
+            <a:extLst>
+              <a:ext uri="{28A0092B-C50C-407E-A947-70E740481C1C}">
+                <a14:useLocalDpi xmlns:a14="http://schemas.microsoft.com/office/drawing/2010/main" val="0"/>
+              </a:ext>
+            </a:extLst>
+          </a:blip>
+          <a:srcRect t="11526" b="11526"/>
+          <a:stretch/>
+        </p:blipFill>
+        <p:spPr>
+          <a:xfrm>
+            <a:off x="413121" y="4146231"/>
             <a:ext cx="455144" cy="468000"/>
           </a:xfrm>
           <a:prstGeom prst="ellipse">
@@ -5496,7 +5547,7 @@
         </p:nvSpPr>
         <p:spPr>
           <a:xfrm>
-            <a:off x="975217" y="3433546"/>
+            <a:off x="975217" y="3151628"/>
             <a:ext cx="3109433" cy="861774"/>
           </a:xfrm>
           <a:prstGeom prst="rect">
@@ -5734,10 +5785,10 @@
       </p:sp>
       <p:pic>
         <p:nvPicPr>
-          <p:cNvPr id="12" name="Imagem 11">
+          <p:cNvPr id="28" name="Imagem 27">
             <a:extLst>
               <a:ext uri="{FF2B5EF4-FFF2-40B4-BE49-F238E27FC236}">
-                <a16:creationId xmlns:a16="http://schemas.microsoft.com/office/drawing/2014/main" id="{F577B933-5A81-69AF-F583-10FAAB19AED3}"/>
+                <a16:creationId xmlns:a16="http://schemas.microsoft.com/office/drawing/2014/main" id="{C56D6172-5276-53CE-F4CF-F7ED09C6EC93}"/>
               </a:ext>
             </a:extLst>
           </p:cNvPr>
@@ -5747,7 +5798,7 @@
           <p:nvPr/>
         </p:nvPicPr>
         <p:blipFill>
-          <a:blip r:embed="rId5">
+          <a:blip r:embed="rId6" cstate="print">
             <a:extLst>
               <a:ext uri="{28A0092B-C50C-407E-A947-70E740481C1C}">
                 <a14:useLocalDpi xmlns:a14="http://schemas.microsoft.com/office/drawing/2010/main" val="0"/>
@@ -5759,7 +5810,7 @@
         </p:blipFill>
         <p:spPr>
           <a:xfrm>
-            <a:off x="413121" y="4951068"/>
+            <a:off x="4396799" y="2232387"/>
             <a:ext cx="455144" cy="468000"/>
           </a:xfrm>
           <a:prstGeom prst="ellipse">
@@ -5797,7 +5848,7 @@
         </p:nvSpPr>
         <p:spPr>
           <a:xfrm>
-            <a:off x="975218" y="4950142"/>
+            <a:off x="975217" y="4146231"/>
             <a:ext cx="3221863" cy="861774"/>
           </a:xfrm>
           <a:prstGeom prst="rect">
@@ -6013,57 +6064,6 @@
           </a:p>
         </p:txBody>
       </p:sp>
-      <p:pic>
-        <p:nvPicPr>
-          <p:cNvPr id="28" name="Imagem 27">
-            <a:extLst>
-              <a:ext uri="{FF2B5EF4-FFF2-40B4-BE49-F238E27FC236}">
-                <a16:creationId xmlns:a16="http://schemas.microsoft.com/office/drawing/2014/main" id="{C56D6172-5276-53CE-F4CF-F7ED09C6EC93}"/>
-              </a:ext>
-            </a:extLst>
-          </p:cNvPr>
-          <p:cNvPicPr>
-            <a:picLocks noChangeAspect="1"/>
-          </p:cNvPicPr>
-          <p:nvPr/>
-        </p:nvPicPr>
-        <p:blipFill>
-          <a:blip r:embed="rId6">
-            <a:extLst>
-              <a:ext uri="{28A0092B-C50C-407E-A947-70E740481C1C}">
-                <a14:useLocalDpi xmlns:a14="http://schemas.microsoft.com/office/drawing/2010/main" val="0"/>
-              </a:ext>
-            </a:extLst>
-          </a:blip>
-          <a:srcRect t="11526" b="11526"/>
-          <a:stretch/>
-        </p:blipFill>
-        <p:spPr>
-          <a:xfrm>
-            <a:off x="4396799" y="2323516"/>
-            <a:ext cx="455144" cy="468000"/>
-          </a:xfrm>
-          <a:prstGeom prst="ellipse">
-            <a:avLst/>
-          </a:prstGeom>
-          <a:ln w="63500" cap="rnd">
-            <a:noFill/>
-          </a:ln>
-          <a:effectLst/>
-          <a:scene3d>
-            <a:camera prst="orthographicFront"/>
-            <a:lightRig rig="contrasting" dir="t">
-              <a:rot lat="0" lon="0" rev="3000000"/>
-            </a:lightRig>
-          </a:scene3d>
-          <a:sp3d contourW="7620">
-            <a:bevelT w="95250" h="31750"/>
-            <a:contourClr>
-              <a:srgbClr val="333333"/>
-            </a:contourClr>
-          </a:sp3d>
-        </p:spPr>
-      </p:pic>
       <p:sp>
         <p:nvSpPr>
           <p:cNvPr id="29" name="CaixaDeTexto 28">
@@ -6078,7 +6078,7 @@
         </p:nvSpPr>
         <p:spPr>
           <a:xfrm>
-            <a:off x="4972479" y="2253158"/>
+            <a:off x="4972479" y="2232387"/>
             <a:ext cx="3105655" cy="861774"/>
           </a:xfrm>
           <a:prstGeom prst="rect">
@@ -6313,7 +6313,7 @@
           <p:nvPr/>
         </p:nvPicPr>
         <p:blipFill>
-          <a:blip r:embed="rId7">
+          <a:blip r:embed="rId7" cstate="print">
             <a:extLst>
               <a:ext uri="{28A0092B-C50C-407E-A947-70E740481C1C}">
                 <a14:useLocalDpi xmlns:a14="http://schemas.microsoft.com/office/drawing/2010/main" val="0"/>
@@ -6325,7 +6325,7 @@
         </p:blipFill>
         <p:spPr>
           <a:xfrm>
-            <a:off x="4396799" y="3325897"/>
+            <a:off x="4396799" y="3151628"/>
             <a:ext cx="455144" cy="468000"/>
           </a:xfrm>
           <a:prstGeom prst="ellipse">
@@ -6363,7 +6363,7 @@
         </p:nvSpPr>
         <p:spPr>
           <a:xfrm>
-            <a:off x="4972480" y="3255538"/>
+            <a:off x="4972479" y="3151628"/>
             <a:ext cx="2564247" cy="861774"/>
           </a:xfrm>
           <a:prstGeom prst="rect">
@@ -6886,7 +6886,7 @@
           <p:nvPr/>
         </p:nvPicPr>
         <p:blipFill>
-          <a:blip r:embed="rId8">
+          <a:blip r:embed="rId8" cstate="print">
             <a:extLst>
               <a:ext uri="{28A0092B-C50C-407E-A947-70E740481C1C}">
                 <a14:useLocalDpi xmlns:a14="http://schemas.microsoft.com/office/drawing/2010/main" val="0"/>
@@ -6898,7 +6898,7 @@
         </p:blipFill>
         <p:spPr>
           <a:xfrm>
-            <a:off x="8466471" y="1273599"/>
+            <a:off x="8466471" y="1296476"/>
             <a:ext cx="455144" cy="468000"/>
           </a:xfrm>
           <a:prstGeom prst="ellipse">
@@ -6936,7 +6936,7 @@
         </p:nvSpPr>
         <p:spPr>
           <a:xfrm>
-            <a:off x="9013720" y="1234130"/>
+            <a:off x="9013720" y="1296476"/>
             <a:ext cx="2764933" cy="861774"/>
           </a:xfrm>
           <a:prstGeom prst="rect">
@@ -7166,7 +7166,7 @@
           <p:nvPr/>
         </p:nvPicPr>
         <p:blipFill>
-          <a:blip r:embed="rId9">
+          <a:blip r:embed="rId9" cstate="print">
             <a:extLst>
               <a:ext uri="{28A0092B-C50C-407E-A947-70E740481C1C}">
                 <a14:useLocalDpi xmlns:a14="http://schemas.microsoft.com/office/drawing/2010/main" val="0"/>
@@ -7178,7 +7178,7 @@
         </p:blipFill>
         <p:spPr>
           <a:xfrm>
-            <a:off x="8466471" y="2421671"/>
+            <a:off x="8466471" y="2232387"/>
             <a:ext cx="455144" cy="468000"/>
           </a:xfrm>
           <a:prstGeom prst="ellipse">
@@ -7216,7 +7216,7 @@
         </p:nvSpPr>
         <p:spPr>
           <a:xfrm>
-            <a:off x="9013720" y="2376575"/>
+            <a:off x="9013720" y="2232387"/>
             <a:ext cx="2564247" cy="861774"/>
           </a:xfrm>
           <a:prstGeom prst="rect">
@@ -7662,237 +7662,6 @@
           </p:txBody>
         </p:sp>
       </p:grpSp>
-      <p:sp>
-        <p:nvSpPr>
-          <p:cNvPr id="17" name="CaixaDeTexto 16">
-            <a:extLst>
-              <a:ext uri="{FF2B5EF4-FFF2-40B4-BE49-F238E27FC236}">
-                <a16:creationId xmlns:a16="http://schemas.microsoft.com/office/drawing/2014/main" id="{8E076048-E23E-086D-5DC1-1A9345530E48}"/>
-              </a:ext>
-            </a:extLst>
-          </p:cNvPr>
-          <p:cNvSpPr txBox="1"/>
-          <p:nvPr/>
-        </p:nvSpPr>
-        <p:spPr>
-          <a:xfrm>
-            <a:off x="975218" y="2232387"/>
-            <a:ext cx="3107041" cy="861774"/>
-          </a:xfrm>
-          <a:prstGeom prst="rect">
-            <a:avLst/>
-          </a:prstGeom>
-          <a:noFill/>
-        </p:spPr>
-        <p:txBody>
-          <a:bodyPr wrap="square" lIns="60960" tIns="30480" rIns="60960" bIns="30480" anchor="t">
-            <a:spAutoFit/>
-          </a:bodyPr>
-          <a:lstStyle>
-            <a:defPPr>
-              <a:defRPr lang="en-US"/>
-            </a:defPPr>
-            <a:lvl1pPr marL="0" algn="l" defTabSz="609539" rtl="0" eaLnBrk="1" latinLnBrk="0" hangingPunct="1">
-              <a:defRPr sz="1200" kern="1200">
-                <a:solidFill>
-                  <a:schemeClr val="tx1"/>
-                </a:solidFill>
-                <a:latin typeface="+mn-lt"/>
-                <a:ea typeface="+mn-ea"/>
-                <a:cs typeface="+mn-cs"/>
-              </a:defRPr>
-            </a:lvl1pPr>
-            <a:lvl2pPr marL="304770" algn="l" defTabSz="609539" rtl="0" eaLnBrk="1" latinLnBrk="0" hangingPunct="1">
-              <a:defRPr sz="1200" kern="1200">
-                <a:solidFill>
-                  <a:schemeClr val="tx1"/>
-                </a:solidFill>
-                <a:latin typeface="+mn-lt"/>
-                <a:ea typeface="+mn-ea"/>
-                <a:cs typeface="+mn-cs"/>
-              </a:defRPr>
-            </a:lvl2pPr>
-            <a:lvl3pPr marL="609539" algn="l" defTabSz="609539" rtl="0" eaLnBrk="1" latinLnBrk="0" hangingPunct="1">
-              <a:defRPr sz="1200" kern="1200">
-                <a:solidFill>
-                  <a:schemeClr val="tx1"/>
-                </a:solidFill>
-                <a:latin typeface="+mn-lt"/>
-                <a:ea typeface="+mn-ea"/>
-                <a:cs typeface="+mn-cs"/>
-              </a:defRPr>
-            </a:lvl3pPr>
-            <a:lvl4pPr marL="914309" algn="l" defTabSz="609539" rtl="0" eaLnBrk="1" latinLnBrk="0" hangingPunct="1">
-              <a:defRPr sz="1200" kern="1200">
-                <a:solidFill>
-                  <a:schemeClr val="tx1"/>
-                </a:solidFill>
-                <a:latin typeface="+mn-lt"/>
-                <a:ea typeface="+mn-ea"/>
-                <a:cs typeface="+mn-cs"/>
-              </a:defRPr>
-            </a:lvl4pPr>
-            <a:lvl5pPr marL="1219078" algn="l" defTabSz="609539" rtl="0" eaLnBrk="1" latinLnBrk="0" hangingPunct="1">
-              <a:defRPr sz="1200" kern="1200">
-                <a:solidFill>
-                  <a:schemeClr val="tx1"/>
-                </a:solidFill>
-                <a:latin typeface="+mn-lt"/>
-                <a:ea typeface="+mn-ea"/>
-                <a:cs typeface="+mn-cs"/>
-              </a:defRPr>
-            </a:lvl5pPr>
-            <a:lvl6pPr marL="1523848" algn="l" defTabSz="609539" rtl="0" eaLnBrk="1" latinLnBrk="0" hangingPunct="1">
-              <a:defRPr sz="1200" kern="1200">
-                <a:solidFill>
-                  <a:schemeClr val="tx1"/>
-                </a:solidFill>
-                <a:latin typeface="+mn-lt"/>
-                <a:ea typeface="+mn-ea"/>
-                <a:cs typeface="+mn-cs"/>
-              </a:defRPr>
-            </a:lvl6pPr>
-            <a:lvl7pPr marL="1828617" algn="l" defTabSz="609539" rtl="0" eaLnBrk="1" latinLnBrk="0" hangingPunct="1">
-              <a:defRPr sz="1200" kern="1200">
-                <a:solidFill>
-                  <a:schemeClr val="tx1"/>
-                </a:solidFill>
-                <a:latin typeface="+mn-lt"/>
-                <a:ea typeface="+mn-ea"/>
-                <a:cs typeface="+mn-cs"/>
-              </a:defRPr>
-            </a:lvl7pPr>
-            <a:lvl8pPr marL="2133387" algn="l" defTabSz="609539" rtl="0" eaLnBrk="1" latinLnBrk="0" hangingPunct="1">
-              <a:defRPr sz="1200" kern="1200">
-                <a:solidFill>
-                  <a:schemeClr val="tx1"/>
-                </a:solidFill>
-                <a:latin typeface="+mn-lt"/>
-                <a:ea typeface="+mn-ea"/>
-                <a:cs typeface="+mn-cs"/>
-              </a:defRPr>
-            </a:lvl8pPr>
-            <a:lvl9pPr marL="2438156" algn="l" defTabSz="609539" rtl="0" eaLnBrk="1" latinLnBrk="0" hangingPunct="1">
-              <a:defRPr sz="1200" kern="1200">
-                <a:solidFill>
-                  <a:schemeClr val="tx1"/>
-                </a:solidFill>
-                <a:latin typeface="+mn-lt"/>
-                <a:ea typeface="+mn-ea"/>
-                <a:cs typeface="+mn-cs"/>
-              </a:defRPr>
-            </a:lvl9pPr>
-          </a:lstStyle>
-          <a:p>
-            <a:pPr algn="l">
-              <a:lnSpc>
-                <a:spcPct val="100000"/>
-              </a:lnSpc>
-            </a:pPr>
-            <a:r>
-              <a:rPr lang="pt-BR" sz="1000" dirty="0">
-                <a:latin typeface="Calibri"/>
-                <a:ea typeface="Calibri"/>
-                <a:cs typeface="Calibri"/>
-              </a:rPr>
-              <a:t>GESIANE LETICIA ALVES | 34  - 4/AP</a:t>
-            </a:r>
-          </a:p>
-          <a:p>
-            <a:pPr algn="l">
-              <a:lnSpc>
-                <a:spcPct val="100000"/>
-              </a:lnSpc>
-            </a:pPr>
-            <a:r>
-              <a:rPr lang="en-US" sz="1000">
-                <a:latin typeface="Calibri"/>
-                <a:ea typeface="Calibri"/>
-                <a:cs typeface="Calibri"/>
-              </a:rPr>
-              <a:t>REFRAC &amp; STEEL. SERV OP SR MANAGER</a:t>
-            </a:r>
-          </a:p>
-          <a:p>
-            <a:r>
-              <a:rPr lang="pt-BR" sz="800">
-                <a:solidFill>
-                  <a:schemeClr val="bg1"/>
-                </a:solidFill>
-                <a:highlight>
-                  <a:srgbClr val="84BD00"/>
-                </a:highlight>
-                <a:latin typeface="Aptos Narrow"/>
-                <a:ea typeface="Calibri"/>
-                <a:cs typeface="Calibri"/>
-              </a:rPr>
-              <a:t>Sucessor Imediato</a:t>
-            </a:r>
-            <a:endParaRPr lang="en-US" sz="800">
-              <a:solidFill>
-                <a:srgbClr val="000000"/>
-              </a:solidFill>
-              <a:latin typeface="Aptos Narrow"/>
-              <a:ea typeface="Calibri"/>
-              <a:cs typeface="Calibri"/>
-            </a:endParaRPr>
-          </a:p>
-          <a:p>
-            <a:r>
-              <a:rPr lang="pt-BR" sz="800">
-                <a:solidFill>
-                  <a:srgbClr val="242424"/>
-                </a:solidFill>
-                <a:latin typeface="Aptos Narrow"/>
-                <a:ea typeface="Calibri"/>
-                <a:cs typeface="Calibri"/>
-              </a:rPr>
-              <a:t>LOREM</a:t>
-            </a:r>
-            <a:endParaRPr lang="en-US"/>
-          </a:p>
-          <a:p>
-            <a:pPr algn="l">
-              <a:lnSpc>
-                <a:spcPct val="100000"/>
-              </a:lnSpc>
-            </a:pPr>
-            <a:r>
-              <a:rPr lang="pt-BR" sz="800">
-                <a:solidFill>
-                  <a:schemeClr val="bg1"/>
-                </a:solidFill>
-                <a:highlight>
-                  <a:srgbClr val="0000FF"/>
-                </a:highlight>
-                <a:latin typeface="Aptos Narrow"/>
-                <a:ea typeface="Calibri"/>
-                <a:cs typeface="Calibri"/>
-              </a:rPr>
-              <a:t>Em desenvolvimento</a:t>
-            </a:r>
-          </a:p>
-          <a:p>
-            <a:pPr algn="l">
-              <a:lnSpc>
-                <a:spcPct val="100000"/>
-              </a:lnSpc>
-            </a:pPr>
-            <a:r>
-              <a:rPr lang="pt-BR" sz="800">
-                <a:solidFill>
-                  <a:srgbClr val="242424"/>
-                </a:solidFill>
-                <a:latin typeface="Aptos Narrow"/>
-                <a:ea typeface="Calibri"/>
-                <a:cs typeface="Calibri"/>
-              </a:rPr>
-              <a:t>LOREM</a:t>
-            </a:r>
-            <a:endParaRPr lang="pt-BR"/>
-          </a:p>
-        </p:txBody>
-      </p:sp>
       <p:pic>
         <p:nvPicPr>
           <p:cNvPr id="18" name="Imagem 17">
@@ -7908,7 +7677,7 @@
           <p:nvPr/>
         </p:nvPicPr>
         <p:blipFill>
-          <a:blip r:embed="rId10">
+          <a:blip r:embed="rId10" cstate="print">
             <a:extLst>
               <a:ext uri="{28A0092B-C50C-407E-A947-70E740481C1C}">
                 <a14:useLocalDpi xmlns:a14="http://schemas.microsoft.com/office/drawing/2010/main" val="0"/>
@@ -7920,7 +7689,7 @@
         </p:blipFill>
         <p:spPr>
           <a:xfrm>
-            <a:off x="413121" y="2303402"/>
+            <a:off x="413121" y="2232387"/>
             <a:ext cx="455144" cy="468000"/>
           </a:xfrm>
           <a:prstGeom prst="ellipse">
@@ -7946,6 +7715,237 @@
       </p:pic>
       <p:sp>
         <p:nvSpPr>
+          <p:cNvPr id="17" name="CaixaDeTexto 16">
+            <a:extLst>
+              <a:ext uri="{FF2B5EF4-FFF2-40B4-BE49-F238E27FC236}">
+                <a16:creationId xmlns:a16="http://schemas.microsoft.com/office/drawing/2014/main" id="{8E076048-E23E-086D-5DC1-1A9345530E48}"/>
+              </a:ext>
+            </a:extLst>
+          </p:cNvPr>
+          <p:cNvSpPr txBox="1"/>
+          <p:nvPr/>
+        </p:nvSpPr>
+        <p:spPr>
+          <a:xfrm>
+            <a:off x="975217" y="2232387"/>
+            <a:ext cx="3107041" cy="861774"/>
+          </a:xfrm>
+          <a:prstGeom prst="rect">
+            <a:avLst/>
+          </a:prstGeom>
+          <a:noFill/>
+        </p:spPr>
+        <p:txBody>
+          <a:bodyPr wrap="square" lIns="60960" tIns="30480" rIns="60960" bIns="30480" anchor="t">
+            <a:spAutoFit/>
+          </a:bodyPr>
+          <a:lstStyle>
+            <a:defPPr>
+              <a:defRPr lang="en-US"/>
+            </a:defPPr>
+            <a:lvl1pPr marL="0" algn="l" defTabSz="609539" rtl="0" eaLnBrk="1" latinLnBrk="0" hangingPunct="1">
+              <a:defRPr sz="1200" kern="1200">
+                <a:solidFill>
+                  <a:schemeClr val="tx1"/>
+                </a:solidFill>
+                <a:latin typeface="+mn-lt"/>
+                <a:ea typeface="+mn-ea"/>
+                <a:cs typeface="+mn-cs"/>
+              </a:defRPr>
+            </a:lvl1pPr>
+            <a:lvl2pPr marL="304770" algn="l" defTabSz="609539" rtl="0" eaLnBrk="1" latinLnBrk="0" hangingPunct="1">
+              <a:defRPr sz="1200" kern="1200">
+                <a:solidFill>
+                  <a:schemeClr val="tx1"/>
+                </a:solidFill>
+                <a:latin typeface="+mn-lt"/>
+                <a:ea typeface="+mn-ea"/>
+                <a:cs typeface="+mn-cs"/>
+              </a:defRPr>
+            </a:lvl2pPr>
+            <a:lvl3pPr marL="609539" algn="l" defTabSz="609539" rtl="0" eaLnBrk="1" latinLnBrk="0" hangingPunct="1">
+              <a:defRPr sz="1200" kern="1200">
+                <a:solidFill>
+                  <a:schemeClr val="tx1"/>
+                </a:solidFill>
+                <a:latin typeface="+mn-lt"/>
+                <a:ea typeface="+mn-ea"/>
+                <a:cs typeface="+mn-cs"/>
+              </a:defRPr>
+            </a:lvl3pPr>
+            <a:lvl4pPr marL="914309" algn="l" defTabSz="609539" rtl="0" eaLnBrk="1" latinLnBrk="0" hangingPunct="1">
+              <a:defRPr sz="1200" kern="1200">
+                <a:solidFill>
+                  <a:schemeClr val="tx1"/>
+                </a:solidFill>
+                <a:latin typeface="+mn-lt"/>
+                <a:ea typeface="+mn-ea"/>
+                <a:cs typeface="+mn-cs"/>
+              </a:defRPr>
+            </a:lvl4pPr>
+            <a:lvl5pPr marL="1219078" algn="l" defTabSz="609539" rtl="0" eaLnBrk="1" latinLnBrk="0" hangingPunct="1">
+              <a:defRPr sz="1200" kern="1200">
+                <a:solidFill>
+                  <a:schemeClr val="tx1"/>
+                </a:solidFill>
+                <a:latin typeface="+mn-lt"/>
+                <a:ea typeface="+mn-ea"/>
+                <a:cs typeface="+mn-cs"/>
+              </a:defRPr>
+            </a:lvl5pPr>
+            <a:lvl6pPr marL="1523848" algn="l" defTabSz="609539" rtl="0" eaLnBrk="1" latinLnBrk="0" hangingPunct="1">
+              <a:defRPr sz="1200" kern="1200">
+                <a:solidFill>
+                  <a:schemeClr val="tx1"/>
+                </a:solidFill>
+                <a:latin typeface="+mn-lt"/>
+                <a:ea typeface="+mn-ea"/>
+                <a:cs typeface="+mn-cs"/>
+              </a:defRPr>
+            </a:lvl6pPr>
+            <a:lvl7pPr marL="1828617" algn="l" defTabSz="609539" rtl="0" eaLnBrk="1" latinLnBrk="0" hangingPunct="1">
+              <a:defRPr sz="1200" kern="1200">
+                <a:solidFill>
+                  <a:schemeClr val="tx1"/>
+                </a:solidFill>
+                <a:latin typeface="+mn-lt"/>
+                <a:ea typeface="+mn-ea"/>
+                <a:cs typeface="+mn-cs"/>
+              </a:defRPr>
+            </a:lvl7pPr>
+            <a:lvl8pPr marL="2133387" algn="l" defTabSz="609539" rtl="0" eaLnBrk="1" latinLnBrk="0" hangingPunct="1">
+              <a:defRPr sz="1200" kern="1200">
+                <a:solidFill>
+                  <a:schemeClr val="tx1"/>
+                </a:solidFill>
+                <a:latin typeface="+mn-lt"/>
+                <a:ea typeface="+mn-ea"/>
+                <a:cs typeface="+mn-cs"/>
+              </a:defRPr>
+            </a:lvl8pPr>
+            <a:lvl9pPr marL="2438156" algn="l" defTabSz="609539" rtl="0" eaLnBrk="1" latinLnBrk="0" hangingPunct="1">
+              <a:defRPr sz="1200" kern="1200">
+                <a:solidFill>
+                  <a:schemeClr val="tx1"/>
+                </a:solidFill>
+                <a:latin typeface="+mn-lt"/>
+                <a:ea typeface="+mn-ea"/>
+                <a:cs typeface="+mn-cs"/>
+              </a:defRPr>
+            </a:lvl9pPr>
+          </a:lstStyle>
+          <a:p>
+            <a:pPr algn="l">
+              <a:lnSpc>
+                <a:spcPct val="100000"/>
+              </a:lnSpc>
+            </a:pPr>
+            <a:r>
+              <a:rPr lang="pt-BR" sz="1000" dirty="0">
+                <a:latin typeface="Calibri"/>
+                <a:ea typeface="Calibri"/>
+                <a:cs typeface="Calibri"/>
+              </a:rPr>
+              <a:t>GESIANE LETICIA ALVES | 34  - 4/AP</a:t>
+            </a:r>
+          </a:p>
+          <a:p>
+            <a:pPr algn="l">
+              <a:lnSpc>
+                <a:spcPct val="100000"/>
+              </a:lnSpc>
+            </a:pPr>
+            <a:r>
+              <a:rPr lang="en-US" sz="1000">
+                <a:latin typeface="Calibri"/>
+                <a:ea typeface="Calibri"/>
+                <a:cs typeface="Calibri"/>
+              </a:rPr>
+              <a:t>REFRAC &amp; STEEL. SERV OP SR MANAGER</a:t>
+            </a:r>
+          </a:p>
+          <a:p>
+            <a:r>
+              <a:rPr lang="pt-BR" sz="800">
+                <a:solidFill>
+                  <a:schemeClr val="bg1"/>
+                </a:solidFill>
+                <a:highlight>
+                  <a:srgbClr val="84BD00"/>
+                </a:highlight>
+                <a:latin typeface="Aptos Narrow"/>
+                <a:ea typeface="Calibri"/>
+                <a:cs typeface="Calibri"/>
+              </a:rPr>
+              <a:t>Sucessor Imediato</a:t>
+            </a:r>
+            <a:endParaRPr lang="en-US" sz="800">
+              <a:solidFill>
+                <a:srgbClr val="000000"/>
+              </a:solidFill>
+              <a:latin typeface="Aptos Narrow"/>
+              <a:ea typeface="Calibri"/>
+              <a:cs typeface="Calibri"/>
+            </a:endParaRPr>
+          </a:p>
+          <a:p>
+            <a:r>
+              <a:rPr lang="pt-BR" sz="800">
+                <a:solidFill>
+                  <a:srgbClr val="242424"/>
+                </a:solidFill>
+                <a:latin typeface="Aptos Narrow"/>
+                <a:ea typeface="Calibri"/>
+                <a:cs typeface="Calibri"/>
+              </a:rPr>
+              <a:t>LOREM</a:t>
+            </a:r>
+            <a:endParaRPr lang="en-US"/>
+          </a:p>
+          <a:p>
+            <a:pPr algn="l">
+              <a:lnSpc>
+                <a:spcPct val="100000"/>
+              </a:lnSpc>
+            </a:pPr>
+            <a:r>
+              <a:rPr lang="pt-BR" sz="800">
+                <a:solidFill>
+                  <a:schemeClr val="bg1"/>
+                </a:solidFill>
+                <a:highlight>
+                  <a:srgbClr val="0000FF"/>
+                </a:highlight>
+                <a:latin typeface="Aptos Narrow"/>
+                <a:ea typeface="Calibri"/>
+                <a:cs typeface="Calibri"/>
+              </a:rPr>
+              <a:t>Em desenvolvimento</a:t>
+            </a:r>
+          </a:p>
+          <a:p>
+            <a:pPr algn="l">
+              <a:lnSpc>
+                <a:spcPct val="100000"/>
+              </a:lnSpc>
+            </a:pPr>
+            <a:r>
+              <a:rPr lang="pt-BR" sz="800">
+                <a:solidFill>
+                  <a:srgbClr val="242424"/>
+                </a:solidFill>
+                <a:latin typeface="Aptos Narrow"/>
+                <a:ea typeface="Calibri"/>
+                <a:cs typeface="Calibri"/>
+              </a:rPr>
+              <a:t>LOREM</a:t>
+            </a:r>
+            <a:endParaRPr lang="pt-BR"/>
+          </a:p>
+        </p:txBody>
+      </p:sp>
+      <p:sp>
+        <p:nvSpPr>
           <p:cNvPr id="21" name="CaixaDeTexto 20">
             <a:extLst>
               <a:ext uri="{FF2B5EF4-FFF2-40B4-BE49-F238E27FC236}">
@@ -7958,7 +7958,7 @@
         </p:nvSpPr>
         <p:spPr>
           <a:xfrm>
-            <a:off x="4972480" y="1234130"/>
+            <a:off x="4972479" y="1296476"/>
             <a:ext cx="2764933" cy="861774"/>
           </a:xfrm>
           <a:prstGeom prst="rect">
@@ -8087,7 +8087,7 @@
               </a:lnSpc>
             </a:pPr>
             <a:r>
-              <a:rPr lang="en-US" sz="1000">
+              <a:rPr lang="en-US" sz="1000" dirty="0">
                 <a:latin typeface="Calibri"/>
                 <a:ea typeface="Calibri"/>
                 <a:cs typeface="Calibri"/>
@@ -8097,7 +8097,7 @@
           </a:p>
           <a:p>
             <a:r>
-              <a:rPr lang="pt-BR" sz="800">
+              <a:rPr lang="pt-BR" sz="800" dirty="0">
                 <a:solidFill>
                   <a:schemeClr val="bg1"/>
                 </a:solidFill>
@@ -8110,7 +8110,7 @@
               </a:rPr>
               <a:t>Sucessor Imediato</a:t>
             </a:r>
-            <a:endParaRPr lang="en-US" sz="800">
+            <a:endParaRPr lang="en-US" sz="800" dirty="0">
               <a:solidFill>
                 <a:schemeClr val="bg1"/>
               </a:solidFill>
@@ -8121,7 +8121,7 @@
           </a:p>
           <a:p>
             <a:r>
-              <a:rPr lang="pt-BR" sz="800">
+              <a:rPr lang="pt-BR" sz="800" dirty="0">
                 <a:solidFill>
                   <a:srgbClr val="242424"/>
                 </a:solidFill>
@@ -8131,7 +8131,7 @@
               </a:rPr>
               <a:t>LOREM</a:t>
             </a:r>
-            <a:endParaRPr lang="pt-BR"/>
+            <a:endParaRPr lang="pt-BR" dirty="0"/>
           </a:p>
           <a:p>
             <a:pPr algn="l">
@@ -8140,7 +8140,7 @@
               </a:lnSpc>
             </a:pPr>
             <a:r>
-              <a:rPr lang="pt-BR" sz="800">
+              <a:rPr lang="pt-BR" sz="800" dirty="0">
                 <a:solidFill>
                   <a:schemeClr val="bg1"/>
                 </a:solidFill>
@@ -8161,7 +8161,7 @@
               </a:lnSpc>
             </a:pPr>
             <a:r>
-              <a:rPr lang="pt-BR" sz="800">
+              <a:rPr lang="pt-BR" sz="800" dirty="0">
                 <a:solidFill>
                   <a:srgbClr val="242424"/>
                 </a:solidFill>
@@ -8171,7 +8171,7 @@
               </a:rPr>
               <a:t>LOREM</a:t>
             </a:r>
-            <a:endParaRPr lang="pt-BR"/>
+            <a:endParaRPr lang="pt-BR" dirty="0"/>
           </a:p>
         </p:txBody>
       </p:sp>
@@ -8384,7 +8384,7 @@
         </p:nvSpPr>
         <p:spPr>
           <a:xfrm>
-            <a:off x="4972480" y="4842428"/>
+            <a:off x="4972479" y="4146231"/>
             <a:ext cx="2764933" cy="861774"/>
           </a:xfrm>
           <a:prstGeom prst="rect">
@@ -8513,7 +8513,7 @@
               </a:lnSpc>
             </a:pPr>
             <a:r>
-              <a:rPr lang="en-US" sz="1000">
+              <a:rPr lang="en-US" sz="1000" dirty="0">
                 <a:latin typeface="Calibri"/>
                 <a:ea typeface="Calibri"/>
                 <a:cs typeface="Calibri"/>
@@ -8528,7 +8528,7 @@
               </a:lnSpc>
             </a:pPr>
             <a:r>
-              <a:rPr lang="pt-BR" sz="800">
+              <a:rPr lang="pt-BR" sz="800" dirty="0">
                 <a:solidFill>
                   <a:schemeClr val="bg1"/>
                 </a:solidFill>
@@ -8540,7 +8540,7 @@
               </a:rPr>
               <a:t>Sucessor Imediato</a:t>
             </a:r>
-            <a:endParaRPr lang="en-US">
+            <a:endParaRPr lang="en-US" dirty="0">
               <a:solidFill>
                 <a:schemeClr val="bg1"/>
               </a:solidFill>
@@ -8548,7 +8548,7 @@
           </a:p>
           <a:p>
             <a:r>
-              <a:rPr lang="pt-BR" sz="800">
+              <a:rPr lang="pt-BR" sz="800" dirty="0">
                 <a:solidFill>
                   <a:srgbClr val="242424"/>
                 </a:solidFill>
@@ -8558,11 +8558,11 @@
               </a:rPr>
               <a:t>LOREM</a:t>
             </a:r>
-            <a:endParaRPr lang="pt-BR"/>
-          </a:p>
-          <a:p>
-            <a:r>
-              <a:rPr lang="pt-BR" sz="800">
+            <a:endParaRPr lang="pt-BR" dirty="0"/>
+          </a:p>
+          <a:p>
+            <a:r>
+              <a:rPr lang="pt-BR" sz="800" dirty="0">
                 <a:solidFill>
                   <a:schemeClr val="bg1"/>
                 </a:solidFill>
@@ -8575,7 +8575,7 @@
               </a:rPr>
               <a:t>Em desenvolvimento</a:t>
             </a:r>
-            <a:endParaRPr lang="pt-BR">
+            <a:endParaRPr lang="pt-BR" dirty="0">
               <a:solidFill>
                 <a:schemeClr val="bg1"/>
               </a:solidFill>
@@ -8583,7 +8583,7 @@
           </a:p>
           <a:p>
             <a:r>
-              <a:rPr lang="pt-BR" sz="800">
+              <a:rPr lang="pt-BR" sz="800" dirty="0">
                 <a:solidFill>
                   <a:srgbClr val="242424"/>
                 </a:solidFill>
@@ -8593,7 +8593,7 @@
               </a:rPr>
               <a:t>LOREM</a:t>
             </a:r>
-            <a:endParaRPr lang="pt-BR"/>
+            <a:endParaRPr lang="pt-BR" dirty="0"/>
           </a:p>
         </p:txBody>
       </p:sp>
@@ -8767,7 +8767,7 @@
           <p:nvPr/>
         </p:nvPicPr>
         <p:blipFill>
-          <a:blip r:embed="rId11">
+          <a:blip r:embed="rId11" cstate="print">
             <a:extLst>
               <a:ext uri="{28A0092B-C50C-407E-A947-70E740481C1C}">
                 <a14:useLocalDpi xmlns:a14="http://schemas.microsoft.com/office/drawing/2010/main" val="0"/>
@@ -8779,7 +8779,7 @@
         </p:blipFill>
         <p:spPr>
           <a:xfrm>
-            <a:off x="4396799" y="1329472"/>
+            <a:off x="4396799" y="1296476"/>
             <a:ext cx="455144" cy="468000"/>
           </a:xfrm>
           <a:prstGeom prst="ellipse">
@@ -8818,7 +8818,7 @@
           <p:nvPr/>
         </p:nvPicPr>
         <p:blipFill>
-          <a:blip r:embed="rId12">
+          <a:blip r:embed="rId12" cstate="print">
             <a:extLst>
               <a:ext uri="{28A0092B-C50C-407E-A947-70E740481C1C}">
                 <a14:useLocalDpi xmlns:a14="http://schemas.microsoft.com/office/drawing/2010/main" val="0"/>
@@ -8830,7 +8830,7 @@
         </p:blipFill>
         <p:spPr>
           <a:xfrm>
-            <a:off x="4396799" y="4879168"/>
+            <a:off x="4396799" y="4146231"/>
             <a:ext cx="455144" cy="468000"/>
           </a:xfrm>
           <a:prstGeom prst="ellipse">
@@ -8869,7 +8869,7 @@
           <p:nvPr/>
         </p:nvPicPr>
         <p:blipFill>
-          <a:blip r:embed="rId13">
+          <a:blip r:embed="rId13" cstate="print">
             <a:extLst>
               <a:ext uri="{28A0092B-C50C-407E-A947-70E740481C1C}">
                 <a14:useLocalDpi xmlns:a14="http://schemas.microsoft.com/office/drawing/2010/main" val="0"/>
@@ -8881,7 +8881,7 @@
         </p:blipFill>
         <p:spPr>
           <a:xfrm>
-            <a:off x="8466471" y="3695237"/>
+            <a:off x="8466471" y="3151628"/>
             <a:ext cx="455144" cy="468000"/>
           </a:xfrm>
           <a:prstGeom prst="ellipse">
@@ -8919,7 +8919,7 @@
         </p:nvSpPr>
         <p:spPr>
           <a:xfrm>
-            <a:off x="9067553" y="3624879"/>
+            <a:off x="9013720" y="3151628"/>
             <a:ext cx="2564247" cy="861774"/>
           </a:xfrm>
           <a:prstGeom prst="rect">
@@ -9156,7 +9156,7 @@
         </p:nvSpPr>
         <p:spPr>
           <a:xfrm>
-            <a:off x="9063694" y="4842428"/>
+            <a:off x="9013720" y="4146231"/>
             <a:ext cx="2764933" cy="861774"/>
           </a:xfrm>
           <a:prstGeom prst="rect">
@@ -9389,7 +9389,7 @@
           <p:nvPr/>
         </p:nvPicPr>
         <p:blipFill>
-          <a:blip r:embed="rId12">
+          <a:blip r:embed="rId12" cstate="print">
             <a:extLst>
               <a:ext uri="{28A0092B-C50C-407E-A947-70E740481C1C}">
                 <a14:useLocalDpi xmlns:a14="http://schemas.microsoft.com/office/drawing/2010/main" val="0"/>
@@ -9401,7 +9401,7 @@
         </p:blipFill>
         <p:spPr>
           <a:xfrm>
-            <a:off x="8488013" y="4879168"/>
+            <a:off x="8466471" y="4146231"/>
             <a:ext cx="455144" cy="468000"/>
           </a:xfrm>
           <a:prstGeom prst="ellipse">

</xml_diff>

<commit_message>
Refactor talent review logic to remove CEO fields and update related tests; enhance text replacement functionality
</commit_message>
<xml_diff>
--- a/carometros/CarometroTalentReview.pptx
+++ b/carometros/CarometroTalentReview.pptx
@@ -4951,7 +4951,7 @@
                   <a:schemeClr val="bg1"/>
                 </a:solidFill>
               </a:rPr>
-              <a:t>CEO3</a:t>
+              <a:t>NomeCadeira</a:t>
             </a:r>
             <a:endParaRPr lang="pt-BR"/>
           </a:p>
@@ -5197,7 +5197,7 @@
               </a:pPr>
               <a:r>
                 <a:rPr lang="pt-BR" sz="1000" dirty="0"/>
-                <a:t>CEO4</a:t>
+                <a:t>NomeCadeira</a:t>
               </a:r>
               <a:endParaRPr lang="pt-BR" dirty="0"/>
             </a:p>
@@ -5386,7 +5386,7 @@
                 <a:ea typeface="Calibri"/>
                 <a:cs typeface="Calibri"/>
               </a:rPr>
-              <a:t>LOREM</a:t>
+              <a:t>NomeCadeira</a:t>
             </a:r>
             <a:endParaRPr lang="pt-BR"/>
           </a:p>
@@ -5426,7 +5426,7 @@
                 <a:ea typeface="Calibri"/>
                 <a:cs typeface="Calibri"/>
               </a:rPr>
-              <a:t>LOREM</a:t>
+              <a:t>NomeCadeira</a:t>
             </a:r>
           </a:p>
         </p:txBody>
@@ -5734,7 +5734,7 @@
                 </a:solidFill>
                 <a:latin typeface="Aptos Narrow"/>
               </a:rPr>
-              <a:t>LOREM</a:t>
+              <a:t>NomeCadeira</a:t>
             </a:r>
             <a:endParaRPr lang="pt-BR"/>
           </a:p>
@@ -5772,7 +5772,7 @@
                 </a:solidFill>
                 <a:latin typeface="Aptos Narrow"/>
               </a:rPr>
-              <a:t>LOREM</a:t>
+              <a:t>NomeCadeira</a:t>
             </a:r>
             <a:endParaRPr lang="pt-BR" sz="800" b="0">
               <a:solidFill>
@@ -6023,7 +6023,7 @@
                 </a:solidFill>
                 <a:latin typeface="Aptos Narrow"/>
               </a:rPr>
-              <a:t>LOREM</a:t>
+              <a:t>NomeCadeira</a:t>
             </a:r>
           </a:p>
           <a:p>
@@ -6059,7 +6059,7 @@
                 </a:solidFill>
                 <a:latin typeface="Aptos Narrow"/>
               </a:rPr>
-              <a:t>LOREM</a:t>
+              <a:t>NomeCadeira</a:t>
             </a:r>
           </a:p>
         </p:txBody>
@@ -6254,7 +6254,7 @@
                 <a:ea typeface="Calibri"/>
                 <a:cs typeface="Calibri"/>
               </a:rPr>
-              <a:t>LOREM</a:t>
+              <a:t>NomeCadeira</a:t>
             </a:r>
             <a:endParaRPr lang="en-US"/>
           </a:p>
@@ -6287,7 +6287,7 @@
                 </a:solidFill>
                 <a:latin typeface="Aptos Narrow"/>
               </a:rPr>
-              <a:t>LOREM</a:t>
+              <a:t>NomeCadeira</a:t>
             </a:r>
             <a:endParaRPr lang="pt-BR" sz="800" b="0">
               <a:solidFill>
@@ -6533,7 +6533,7 @@
                 </a:solidFill>
                 <a:latin typeface="Aptos Narrow"/>
               </a:rPr>
-              <a:t>LOREM</a:t>
+              <a:t>NomeCadeira</a:t>
             </a:r>
             <a:endParaRPr lang="pt-BR"/>
           </a:p>
@@ -6570,7 +6570,7 @@
                 </a:solidFill>
                 <a:latin typeface="Aptos Narrow"/>
               </a:rPr>
-              <a:t>LOREM</a:t>
+              <a:t>NomeCadeira</a:t>
             </a:r>
             <a:endParaRPr lang="en-US" sz="800" b="0">
               <a:solidFill>
@@ -6865,7 +6865,7 @@
                   <a:schemeClr val="bg1"/>
                 </a:solidFill>
               </a:rPr>
-              <a:t>CEO3</a:t>
+              <a:t>NomeCadeira</a:t>
             </a:r>
             <a:endParaRPr lang="pt-BR"/>
           </a:p>
@@ -7106,7 +7106,7 @@
                 </a:solidFill>
                 <a:latin typeface="Aptos Narrow"/>
               </a:rPr>
-              <a:t>LOREM</a:t>
+              <a:t>NomeCadeira</a:t>
             </a:r>
             <a:endParaRPr lang="pt-BR">
               <a:solidFill>
@@ -7146,7 +7146,7 @@
                 </a:solidFill>
                 <a:latin typeface="Aptos Narrow"/>
               </a:rPr>
-              <a:t>LOREM</a:t>
+              <a:t>NomeCadeira</a:t>
             </a:r>
           </a:p>
         </p:txBody>
@@ -7386,7 +7386,7 @@
                 </a:solidFill>
                 <a:latin typeface="Aptos Narrow"/>
               </a:rPr>
-              <a:t>LOREM</a:t>
+              <a:t>NomeCadeira</a:t>
             </a:r>
             <a:endParaRPr lang="pt-BR"/>
           </a:p>
@@ -7423,7 +7423,7 @@
                 </a:solidFill>
                 <a:latin typeface="Aptos Narrow"/>
               </a:rPr>
-              <a:t>LOREM</a:t>
+              <a:t>NomeCadeira</a:t>
             </a:r>
             <a:endParaRPr lang="pt-BR" sz="800" b="0">
               <a:solidFill>
@@ -7656,7 +7656,7 @@
               </a:pPr>
               <a:r>
                 <a:rPr lang="pt-BR" sz="1000"/>
-                <a:t>CEO4</a:t>
+                <a:t>NomeCadeira</a:t>
               </a:r>
             </a:p>
           </p:txBody>
@@ -7898,7 +7898,7 @@
                 <a:ea typeface="Calibri"/>
                 <a:cs typeface="Calibri"/>
               </a:rPr>
-              <a:t>LOREM</a:t>
+              <a:t>NomeCadeira</a:t>
             </a:r>
             <a:endParaRPr lang="en-US"/>
           </a:p>
@@ -7938,7 +7938,7 @@
                 <a:ea typeface="Calibri"/>
                 <a:cs typeface="Calibri"/>
               </a:rPr>
-              <a:t>LOREM</a:t>
+              <a:t>NomeCadeira</a:t>
             </a:r>
             <a:endParaRPr lang="pt-BR"/>
           </a:p>
@@ -8129,7 +8129,7 @@
                 <a:ea typeface="Calibri"/>
                 <a:cs typeface="Calibri"/>
               </a:rPr>
-              <a:t>LOREM</a:t>
+              <a:t>NomeCadeira</a:t>
             </a:r>
             <a:endParaRPr lang="pt-BR" dirty="0"/>
           </a:p>
@@ -8169,7 +8169,7 @@
                 <a:ea typeface="Calibri"/>
                 <a:cs typeface="Calibri"/>
               </a:rPr>
-              <a:t>LOREM</a:t>
+              <a:t>NomeCadeira</a:t>
             </a:r>
             <a:endParaRPr lang="pt-BR" dirty="0"/>
           </a:p>
@@ -8364,7 +8364,7 @@
               </a:pPr>
               <a:r>
                 <a:rPr lang="pt-BR" sz="1000"/>
-                <a:t>CEO4</a:t>
+                <a:t>NomeCadeira</a:t>
               </a:r>
             </a:p>
           </p:txBody>
@@ -8556,7 +8556,7 @@
                 <a:ea typeface="Calibri"/>
                 <a:cs typeface="Calibri"/>
               </a:rPr>
-              <a:t>LOREM</a:t>
+              <a:t>NomeCadeira</a:t>
             </a:r>
             <a:endParaRPr lang="pt-BR" dirty="0"/>
           </a:p>
@@ -8591,7 +8591,7 @@
                 <a:ea typeface="Calibri"/>
                 <a:cs typeface="Calibri"/>
               </a:rPr>
-              <a:t>LOREM</a:t>
+              <a:t>NomeCadeira</a:t>
             </a:r>
             <a:endParaRPr lang="pt-BR" dirty="0"/>
           </a:p>
@@ -8746,7 +8746,7 @@
                   <a:schemeClr val="bg1"/>
                 </a:solidFill>
               </a:rPr>
-              <a:t>CEO3</a:t>
+              <a:t>NomeCadeira</a:t>
             </a:r>
             <a:endParaRPr lang="pt-BR"/>
           </a:p>
@@ -9095,7 +9095,7 @@
                 <a:ea typeface="Calibri"/>
                 <a:cs typeface="Calibri"/>
               </a:rPr>
-              <a:t>LOREM</a:t>
+              <a:t>NomeCadeira</a:t>
             </a:r>
             <a:br>
               <a:rPr lang="pt-BR" sz="1000" dirty="0">
@@ -9136,7 +9136,7 @@
                 </a:solidFill>
                 <a:latin typeface="Aptos Narrow"/>
               </a:rPr>
-              <a:t>LOREM</a:t>
+              <a:t>NomeCadeira</a:t>
             </a:r>
             <a:endParaRPr lang="pt-BR"/>
           </a:p>
@@ -9328,7 +9328,7 @@
                 <a:ea typeface="Calibri"/>
                 <a:cs typeface="Calibri"/>
               </a:rPr>
-              <a:t>LOREM</a:t>
+              <a:t>NomeCadeira</a:t>
             </a:r>
             <a:endParaRPr lang="pt-BR"/>
           </a:p>
@@ -9368,7 +9368,7 @@
                 <a:ea typeface="Calibri"/>
                 <a:cs typeface="Calibri"/>
               </a:rPr>
-              <a:t>LOREM</a:t>
+              <a:t>NomeCadeira</a:t>
             </a:r>
             <a:endParaRPr lang="pt-BR"/>
           </a:p>

</xml_diff>

<commit_message>
Update CarometroTalentReview.pptx with revised content
</commit_message>
<xml_diff>
--- a/carometros/CarometroTalentReview.pptx
+++ b/carometros/CarometroTalentReview.pptx
@@ -4946,14 +4946,14 @@
           <a:p>
             <a:pPr defTabSz="412771"/>
             <a:r>
-              <a:rPr lang="pt-BR" sz="1400">
+              <a:rPr lang="pt-BR" sz="1400" dirty="0" err="1">
                 <a:solidFill>
                   <a:schemeClr val="bg1"/>
                 </a:solidFill>
               </a:rPr>
-              <a:t>NomeCadeira</a:t>
-            </a:r>
-            <a:endParaRPr lang="pt-BR"/>
+              <a:t>VicePresidencia</a:t>
+            </a:r>
+            <a:endParaRPr lang="pt-BR" dirty="0"/>
           </a:p>
         </p:txBody>
       </p:sp>
@@ -5197,7 +5197,7 @@
               </a:pPr>
               <a:r>
                 <a:rPr lang="pt-BR" sz="1000" dirty="0"/>
-                <a:t>NomeCadeira</a:t>
+                <a:t>Diretoria</a:t>
               </a:r>
               <a:endParaRPr lang="pt-BR" dirty="0"/>
             </a:p>
@@ -6477,7 +6477,7 @@
               </a:lnSpc>
             </a:pPr>
             <a:r>
-              <a:rPr lang="pt-BR" sz="1000">
+              <a:rPr lang="pt-BR" sz="1000" dirty="0">
                 <a:latin typeface="Calibri"/>
                 <a:ea typeface="Calibri"/>
                 <a:cs typeface="Calibri"/>
@@ -6492,7 +6492,7 @@
               </a:lnSpc>
             </a:pPr>
             <a:r>
-              <a:rPr lang="en-US" sz="1000">
+              <a:rPr lang="en-US" sz="1000" dirty="0">
                 <a:latin typeface="Calibri"/>
                 <a:ea typeface="Calibri"/>
                 <a:cs typeface="Calibri"/>
@@ -6507,7 +6507,7 @@
               </a:rPr>
             </a:br>
             <a:r>
-              <a:rPr lang="pt-BR" sz="800">
+              <a:rPr lang="pt-BR" sz="800" dirty="0">
                 <a:solidFill>
                   <a:schemeClr val="bg1"/>
                 </a:solidFill>
@@ -6527,7 +6527,7 @@
               </a:lnSpc>
             </a:pPr>
             <a:r>
-              <a:rPr lang="pt-BR" sz="800">
+              <a:rPr lang="pt-BR" sz="800" dirty="0" err="1">
                 <a:solidFill>
                   <a:srgbClr val="242424"/>
                 </a:solidFill>
@@ -6535,7 +6535,7 @@
               </a:rPr>
               <a:t>NomeCadeira</a:t>
             </a:r>
-            <a:endParaRPr lang="pt-BR"/>
+            <a:endParaRPr lang="pt-BR" dirty="0"/>
           </a:p>
           <a:p>
             <a:pPr algn="l">
@@ -6544,7 +6544,7 @@
               </a:lnSpc>
             </a:pPr>
             <a:r>
-              <a:rPr lang="pt-BR" sz="800">
+              <a:rPr lang="pt-BR" sz="800" dirty="0">
                 <a:solidFill>
                   <a:schemeClr val="bg1"/>
                 </a:solidFill>
@@ -6564,7 +6564,7 @@
               </a:rPr>
             </a:br>
             <a:r>
-              <a:rPr lang="pt-BR" sz="800">
+              <a:rPr lang="pt-BR" sz="800" dirty="0" err="1">
                 <a:solidFill>
                   <a:srgbClr val="242424"/>
                 </a:solidFill>
@@ -6572,7 +6572,7 @@
               </a:rPr>
               <a:t>NomeCadeira</a:t>
             </a:r>
-            <a:endParaRPr lang="en-US" sz="800" b="0">
+            <a:endParaRPr lang="en-US" sz="800" b="0" dirty="0">
               <a:solidFill>
                 <a:srgbClr val="242424"/>
               </a:solidFill>
@@ -6860,14 +6860,14 @@
           </a:lstStyle>
           <a:p>
             <a:r>
-              <a:rPr lang="pt-BR" sz="1400">
+              <a:rPr lang="pt-BR" sz="1400" dirty="0" err="1">
                 <a:solidFill>
                   <a:schemeClr val="bg1"/>
                 </a:solidFill>
               </a:rPr>
-              <a:t>NomeCadeira</a:t>
-            </a:r>
-            <a:endParaRPr lang="pt-BR"/>
+              <a:t>VicePresidencia</a:t>
+            </a:r>
+            <a:endParaRPr lang="pt-BR" dirty="0"/>
           </a:p>
         </p:txBody>
       </p:sp>
@@ -7649,15 +7649,11 @@
               </a:lvl9pPr>
             </a:lstStyle>
             <a:p>
-              <a:pPr algn="l">
-                <a:lnSpc>
-                  <a:spcPct val="100000"/>
-                </a:lnSpc>
-              </a:pPr>
               <a:r>
                 <a:rPr lang="pt-BR" sz="1000"/>
-                <a:t>NomeCadeira</a:t>
+                <a:t>Diretoria</a:t>
               </a:r>
+              <a:endParaRPr lang="pt-BR" sz="1000" dirty="0"/>
             </a:p>
           </p:txBody>
         </p:sp>
@@ -8357,14 +8353,9 @@
               </a:lvl9pPr>
             </a:lstStyle>
             <a:p>
-              <a:pPr algn="l">
-                <a:lnSpc>
-                  <a:spcPct val="100000"/>
-                </a:lnSpc>
-              </a:pPr>
               <a:r>
-                <a:rPr lang="pt-BR" sz="1000"/>
-                <a:t>NomeCadeira</a:t>
+                <a:rPr lang="pt-BR" sz="1000" dirty="0"/>
+                <a:t>Diretoria</a:t>
               </a:r>
             </a:p>
           </p:txBody>
@@ -8741,14 +8732,14 @@
           <a:p>
             <a:pPr defTabSz="412771"/>
             <a:r>
-              <a:rPr lang="pt-BR" sz="1400">
+              <a:rPr lang="pt-BR" sz="1400" dirty="0" err="1">
                 <a:solidFill>
                   <a:schemeClr val="bg1"/>
                 </a:solidFill>
               </a:rPr>
-              <a:t>NomeCadeira</a:t>
-            </a:r>
-            <a:endParaRPr lang="pt-BR"/>
+              <a:t>VicePresidencia</a:t>
+            </a:r>
+            <a:endParaRPr lang="pt-BR" dirty="0"/>
           </a:p>
         </p:txBody>
       </p:sp>

</xml_diff>